<commit_message>
Update pptx and readme
</commit_message>
<xml_diff>
--- a/AI_Job_Assistant_Design_Deck.pptx
+++ b/AI_Job_Assistant_Design_Deck.pptx
@@ -15,7 +15,6 @@
     <p:sldId id="263" r:id="rId14"/>
     <p:sldId id="264" r:id="rId15"/>
     <p:sldId id="265" r:id="rId16"/>
-    <p:sldId id="266" r:id="rId17"/>
   </p:sldIdLst>
   <p:sldSz cx="9144000" cy="6858000" type="screen4x3"/>
   <p:notesSz cx="6858000" cy="9144000"/>
@@ -3410,7 +3409,7 @@
               </a:defRPr>
             </a:pPr>
             <a:r>
-              <a:t>Learning resources not showing — fixed stream processing to handle parallel nodes</a:t>
+              <a:t>• Learning resources not showing — fixed stream processing to handle parallel nodes</a:t>
             </a:r>
           </a:p>
           <a:p>
@@ -3426,7 +3425,7 @@
               </a:defRPr>
             </a:pPr>
             <a:r>
-              <a:t>LLMs vs Large Language Models not matching — normalized canonical values in skill_normalizer</a:t>
+              <a:t>• LLMs vs Large Language Models not matching — normalized canonical values in skill_normalizer</a:t>
             </a:r>
           </a:p>
           <a:p>
@@ -3442,7 +3441,7 @@
               </a:defRPr>
             </a:pPr>
             <a:r>
-              <a:t>Chart not reflecting skill matches — added _skill_canonical() for chart lookups</a:t>
+              <a:t>• Chart not reflecting skill matches — added _skill_canonical() for chart lookups</a:t>
             </a:r>
           </a:p>
           <a:p>
@@ -3458,7 +3457,7 @@
               </a:defRPr>
             </a:pPr>
             <a:r>
-              <a:t>Tavily returning 0 — surface API errors in resource_search_warnings</a:t>
+              <a:t>• Tavily returning 0 — surface API errors in resource_search_warnings</a:t>
             </a:r>
           </a:p>
           <a:p>
@@ -3474,7 +3473,7 @@
               </a:defRPr>
             </a:pPr>
             <a:r>
-              <a:t>Token limit (429) — truncate JD to 15,000 chars</a:t>
+              <a:t>• Token limit (429) — truncate JD to 15,000 chars</a:t>
             </a:r>
           </a:p>
           <a:p>
@@ -3490,172 +3489,9 @@
               </a:defRPr>
             </a:pPr>
             <a:r>
-              <a:t>Empty skill_gaps when ignoring PLs — added required_skills_for_resources fallback</a:t>
-            </a:r>
-          </a:p>
-        </p:txBody>
-      </p:sp>
-    </p:spTree>
-  </p:cSld>
-  <p:clrMapOvr>
-    <a:masterClrMapping/>
-  </p:clrMapOvr>
-</p:sld>
-</file>
-
-<file path=ppt/slides/slide11.xml><?xml version="1.0" encoding="utf-8"?>
-<p:sld xmlns:a="http://schemas.openxmlformats.org/drawingml/2006/main" xmlns:p="http://schemas.openxmlformats.org/presentationml/2006/main" xmlns:r="http://schemas.openxmlformats.org/officeDocument/2006/relationships">
-  <p:cSld>
-    <p:spTree>
-      <p:nvGrpSpPr>
-        <p:cNvPr id="1" name=""/>
-        <p:cNvGrpSpPr/>
-        <p:nvPr/>
-      </p:nvGrpSpPr>
-      <p:grpSpPr/>
-      <p:sp>
-        <p:nvSpPr>
-          <p:cNvPr id="2" name="Rectangle 1"/>
-          <p:cNvSpPr/>
-          <p:nvPr/>
-        </p:nvSpPr>
-        <p:spPr>
-          <a:xfrm>
-            <a:off x="0" y="0"/>
-            <a:ext cx="9144000" cy="137160"/>
-          </a:xfrm>
-          <a:prstGeom prst="rect">
-            <a:avLst/>
-          </a:prstGeom>
-          <a:solidFill>
-            <a:srgbClr val="0F172A"/>
-          </a:solidFill>
-          <a:ln>
-            <a:noFill/>
-          </a:ln>
-        </p:spPr>
-        <p:style>
-          <a:lnRef idx="1">
-            <a:schemeClr val="accent1"/>
-          </a:lnRef>
-          <a:fillRef idx="3">
-            <a:schemeClr val="accent1"/>
-          </a:fillRef>
-          <a:effectRef idx="2">
-            <a:schemeClr val="accent1"/>
-          </a:effectRef>
-          <a:fontRef idx="minor">
-            <a:schemeClr val="lt1"/>
-          </a:fontRef>
-        </p:style>
-        <p:txBody>
-          <a:bodyPr rtlCol="0" anchor="ctr"/>
-          <a:lstStyle/>
-          <a:p>
-            <a:pPr algn="ctr"/>
-          </a:p>
-        </p:txBody>
-      </p:sp>
-      <p:sp>
-        <p:nvSpPr>
-          <p:cNvPr id="3" name="Rectangle 2"/>
-          <p:cNvSpPr/>
-          <p:nvPr/>
-        </p:nvSpPr>
-        <p:spPr>
-          <a:xfrm>
-            <a:off x="0" y="0"/>
-            <a:ext cx="73152" cy="6858000"/>
-          </a:xfrm>
-          <a:prstGeom prst="rect">
-            <a:avLst/>
-          </a:prstGeom>
-          <a:solidFill>
-            <a:srgbClr val="0D9488"/>
-          </a:solidFill>
-          <a:ln>
-            <a:noFill/>
-          </a:ln>
-        </p:spPr>
-        <p:style>
-          <a:lnRef idx="1">
-            <a:schemeClr val="accent1"/>
-          </a:lnRef>
-          <a:fillRef idx="3">
-            <a:schemeClr val="accent1"/>
-          </a:fillRef>
-          <a:effectRef idx="2">
-            <a:schemeClr val="accent1"/>
-          </a:effectRef>
-          <a:fontRef idx="minor">
-            <a:schemeClr val="lt1"/>
-          </a:fontRef>
-        </p:style>
-        <p:txBody>
-          <a:bodyPr rtlCol="0" anchor="ctr"/>
-          <a:lstStyle/>
-          <a:p>
-            <a:pPr algn="ctr"/>
-          </a:p>
-        </p:txBody>
-      </p:sp>
-      <p:sp>
-        <p:nvSpPr>
-          <p:cNvPr id="4" name="TextBox 3"/>
-          <p:cNvSpPr txBox="1"/>
-          <p:nvPr/>
-        </p:nvSpPr>
-        <p:spPr>
-          <a:xfrm>
-            <a:off x="685800" y="548640"/>
-            <a:ext cx="7772400" cy="822960"/>
-          </a:xfrm>
-          <a:prstGeom prst="rect">
-            <a:avLst/>
-          </a:prstGeom>
-          <a:noFill/>
-        </p:spPr>
-        <p:txBody>
-          <a:bodyPr wrap="none">
-            <a:spAutoFit/>
-          </a:bodyPr>
-          <a:lstStyle/>
-          <a:p>
-            <a:pPr>
-              <a:defRPr sz="2800" b="1">
-                <a:solidFill>
-                  <a:srgbClr val="0F172A"/>
-                </a:solidFill>
-                <a:latin typeface="Segoe UI"/>
-              </a:defRPr>
-            </a:pPr>
-            <a:r>
-              <a:t>Additional Iterations (continued)</a:t>
-            </a:r>
-          </a:p>
-        </p:txBody>
-      </p:sp>
-      <p:sp>
-        <p:nvSpPr>
-          <p:cNvPr id="5" name="TextBox 4"/>
-          <p:cNvSpPr txBox="1"/>
-          <p:nvPr/>
-        </p:nvSpPr>
-        <p:spPr>
-          <a:xfrm>
-            <a:off x="685800" y="1371600"/>
-            <a:ext cx="7772400" cy="5029200"/>
-          </a:xfrm>
-          <a:prstGeom prst="rect">
-            <a:avLst/>
-          </a:prstGeom>
-          <a:noFill/>
-        </p:spPr>
-        <p:txBody>
-          <a:bodyPr wrap="square">
-            <a:spAutoFit/>
-          </a:bodyPr>
-          <a:lstStyle/>
+              <a:t>• Empty skill_gaps when ignoring PLs — added required_skills_for_resources fallback</a:t>
+            </a:r>
+          </a:p>
           <a:p>
             <a:pPr>
               <a:spcBef>
@@ -3669,7 +3505,7 @@
               </a:defRPr>
             </a:pPr>
             <a:r>
-              <a:t>Add skill to resume — override UI with Add/Remove, re-analyze from normalize_skills</a:t>
+              <a:t>• Add skill to resume — override UI with Add/Remove, re-analyze from normalize_skills</a:t>
             </a:r>
           </a:p>
           <a:p>
@@ -3685,7 +3521,7 @@
               </a:defRPr>
             </a:pPr>
             <a:r>
-              <a:t>Export as JSON — build_export_json, download button</a:t>
+              <a:t>• Export as JSON — build_export_json, download button</a:t>
             </a:r>
           </a:p>
           <a:p>
@@ -3701,23 +3537,7 @@
               </a:defRPr>
             </a:pPr>
             <a:r>
-              <a:t>Privacy note — displayed in sidebar</a:t>
-            </a:r>
-          </a:p>
-          <a:p>
-            <a:pPr>
-              <a:spcBef>
-                <a:spcPts val="600"/>
-              </a:spcBef>
-              <a:defRPr sz="1600">
-                <a:solidFill>
-                  <a:srgbClr val="334455"/>
-                </a:solidFill>
-                <a:latin typeface="Segoe UI"/>
-              </a:defRPr>
-            </a:pPr>
-            <a:r>
-              <a:t>Job description via URL — URL input, fetch &amp; parse (truncation applied)</a:t>
+              <a:t>• Privacy note — displayed in sidebar</a:t>
             </a:r>
           </a:p>
         </p:txBody>
@@ -3896,7 +3716,7 @@
               </a:defRPr>
             </a:pPr>
             <a:r>
-              <a:t>Job seekers struggle to identify skill gaps between their resume and job requirements.</a:t>
+              <a:t>• Job seekers struggle to identify skill gaps between their resume and job requirements.</a:t>
             </a:r>
           </a:p>
           <a:p>
@@ -3912,7 +3732,7 @@
               </a:defRPr>
             </a:pPr>
             <a:r>
-              <a:t>Manually comparing a resume to a job description is time-consuming and prone to oversight.</a:t>
+              <a:t>• Manually comparing a resume to a job description is time-consuming and prone to oversight.</a:t>
             </a:r>
           </a:p>
           <a:p>
@@ -3928,7 +3748,7 @@
               </a:defRPr>
             </a:pPr>
             <a:r>
-              <a:t>Finding relevant learning resources for identified gaps is fragmented across many platforms.</a:t>
+              <a:t>• Finding relevant learning resources for identified gaps is fragmented across many platforms.</a:t>
             </a:r>
           </a:p>
           <a:p>
@@ -3944,7 +3764,7 @@
               </a:defRPr>
             </a:pPr>
             <a:r>
-              <a:t>There is no unified tool that automates gap analysis and curates learning resources.</a:t>
+              <a:t>• There is no unified tool that automates gap analysis and curates learning resources.</a:t>
             </a:r>
           </a:p>
           <a:p>
@@ -3960,7 +3780,7 @@
               </a:defRPr>
             </a:pPr>
             <a:r>
-              <a:t>Solution: An AI-powered assistant that analyzes resume vs. JD, identifies gaps, and suggests personalized training resources.</a:t>
+              <a:t>• Solution: An AI-powered assistant that analyzes resume vs. JD, identifies gaps, and suggests personalized training resources.</a:t>
             </a:r>
           </a:p>
         </p:txBody>
@@ -4139,7 +3959,7 @@
               </a:defRPr>
             </a:pPr>
             <a:r>
-              <a:t>AI-powered tool that compares a resume to a software job description.</a:t>
+              <a:t>• AI-powered tool that compares a resume to a software job description.</a:t>
             </a:r>
           </a:p>
           <a:p>
@@ -4155,7 +3975,7 @@
               </a:defRPr>
             </a:pPr>
             <a:r>
-              <a:t>Identifies skill gaps and suggests personalized learning resources.</a:t>
+              <a:t>• Identifies skill gaps and suggests personalized learning resources.</a:t>
             </a:r>
           </a:p>
           <a:p>
@@ -4171,7 +3991,7 @@
               </a:defRPr>
             </a:pPr>
             <a:r>
-              <a:t>Key capabilities:</a:t>
+              <a:t>• Key capabilities:</a:t>
             </a:r>
           </a:p>
           <a:p>
@@ -4187,7 +4007,7 @@
               </a:defRPr>
             </a:pPr>
             <a:r>
-              <a:t>  • Resume analysis — extracts technical &amp; soft skills, rates 1–100</a:t>
+              <a:t>• Resume analysis — extracts technical &amp; soft skills, rates 1–100</a:t>
             </a:r>
           </a:p>
           <a:p>
@@ -4203,7 +4023,7 @@
               </a:defRPr>
             </a:pPr>
             <a:r>
-              <a:t>  • Job description analysis — required skills, industry, domain</a:t>
+              <a:t>• Job description analysis — required skills, industry, domain</a:t>
             </a:r>
           </a:p>
           <a:p>
@@ -4219,7 +4039,7 @@
               </a:defRPr>
             </a:pPr>
             <a:r>
-              <a:t>  • Skill matching — weighted match %, gap detection</a:t>
+              <a:t>• Skill matching — weighted match %, gap detection</a:t>
             </a:r>
           </a:p>
           <a:p>
@@ -4235,7 +4055,7 @@
               </a:defRPr>
             </a:pPr>
             <a:r>
-              <a:t>  • Resource discovery — web, news, YouTube, books, courses</a:t>
+              <a:t>• Resource discovery — web, news, YouTube, books, courses</a:t>
             </a:r>
           </a:p>
           <a:p>
@@ -4251,7 +4071,7 @@
               </a:defRPr>
             </a:pPr>
             <a:r>
-              <a:t>  • Training plan — prioritized, actionable study plan</a:t>
+              <a:t>• Training plan — prioritized, actionable study plan</a:t>
             </a:r>
           </a:p>
         </p:txBody>
@@ -4430,7 +4250,7 @@
               </a:defRPr>
             </a:pPr>
             <a:r>
-              <a:t>Modular orchestration — LangGraph state machine with discrete nodes</a:t>
+              <a:t>• Modular orchestration — LangGraph state machine with discrete nodes</a:t>
             </a:r>
           </a:p>
           <a:p>
@@ -4446,7 +4266,7 @@
               </a:defRPr>
             </a:pPr>
             <a:r>
-              <a:t>Structured outputs — Pydantic models for resume, JD, training plan</a:t>
+              <a:t>• Structured outputs — Pydantic models for resume, JD, training plan</a:t>
             </a:r>
           </a:p>
           <a:p>
@@ -4462,7 +4282,7 @@
               </a:defRPr>
             </a:pPr>
             <a:r>
-              <a:t>Canonical skill mapping — synonyms (LLMs, RAG, K8s) normalized for matching</a:t>
+              <a:t>• Canonical skill mapping — synonyms (LLMs, RAG, K8s) normalized for matching</a:t>
             </a:r>
           </a:p>
           <a:p>
@@ -4478,7 +4298,7 @@
               </a:defRPr>
             </a:pPr>
             <a:r>
-              <a:t>Graceful degradation — missing API keys disable features, not the app</a:t>
+              <a:t>• Graceful degradation — missing API keys disable features, not the app</a:t>
             </a:r>
           </a:p>
           <a:p>
@@ -4494,7 +4314,7 @@
               </a:defRPr>
             </a:pPr>
             <a:r>
-              <a:t>Privacy-first — resume &amp; JD not stored on any server</a:t>
+              <a:t>• Privacy-first — resume &amp; JD not stored on any server</a:t>
             </a:r>
           </a:p>
           <a:p>
@@ -4510,7 +4330,7 @@
               </a:defRPr>
             </a:pPr>
             <a:r>
-              <a:t>User overrides — add skills, adjust ratings, change domain; re-analyze without re-upload</a:t>
+              <a:t>• User overrides — add skills, adjust ratings, change domain; re-analyze without re-upload</a:t>
             </a:r>
           </a:p>
         </p:txBody>
@@ -4689,7 +4509,7 @@
               </a:defRPr>
             </a:pPr>
             <a:r>
-              <a:t>Orchestration: LangGraph (state graph)</a:t>
+              <a:t>• Orchestration: LangGraph (state graph)</a:t>
             </a:r>
           </a:p>
           <a:p>
@@ -4705,7 +4525,7 @@
               </a:defRPr>
             </a:pPr>
             <a:r>
-              <a:t>LLM: OpenAI GPT-4o via LangChain</a:t>
+              <a:t>• LLM: OpenAI GPT-4o via LangChain</a:t>
             </a:r>
           </a:p>
           <a:p>
@@ -4721,7 +4541,7 @@
               </a:defRPr>
             </a:pPr>
             <a:r>
-              <a:t>UI: Streamlit</a:t>
+              <a:t>• UI: Streamlit</a:t>
             </a:r>
           </a:p>
           <a:p>
@@ -4737,7 +4557,7 @@
               </a:defRPr>
             </a:pPr>
             <a:r>
-              <a:t>Web search: Tavily (articles, news, blog, books, courses)</a:t>
+              <a:t>• Web search: Tavily (articles, news, blog, books, courses)</a:t>
             </a:r>
           </a:p>
           <a:p>
@@ -4753,7 +4573,7 @@
               </a:defRPr>
             </a:pPr>
             <a:r>
-              <a:t>Video search: YouTube Data API v3</a:t>
+              <a:t>• Video search: YouTube Data API v3</a:t>
             </a:r>
           </a:p>
           <a:p>
@@ -4769,7 +4589,7 @@
               </a:defRPr>
             </a:pPr>
             <a:r>
-              <a:t>Parsing: PyMuPDF (PDF), python-docx (DOCX), plain TXT</a:t>
+              <a:t>• Parsing: PyMuPDF (PDF), python-docx (DOCX), plain TXT</a:t>
             </a:r>
           </a:p>
         </p:txBody>
@@ -6506,7 +6326,7 @@
               </a:defRPr>
             </a:pPr>
             <a:r>
-              <a:t>GraphState (TypedDict) flows through all nodes</a:t>
+              <a:t>• GraphState (TypedDict) flows through all nodes</a:t>
             </a:r>
           </a:p>
           <a:p>
@@ -6522,7 +6342,7 @@
               </a:defRPr>
             </a:pPr>
             <a:r>
-              <a:t>Inputs: resume_text, job_description, ignore_programming_languages</a:t>
+              <a:t>• Inputs: resume_text, job_description, ignore_programming_languages</a:t>
             </a:r>
           </a:p>
           <a:p>
@@ -6538,7 +6358,7 @@
               </a:defRPr>
             </a:pPr>
             <a:r>
-              <a:t>Resume/JD nodes: user_skills, required_skills, job_title, software_domain</a:t>
+              <a:t>• Resume/JD nodes: user_skills, required_skills, job_title, software_domain</a:t>
             </a:r>
           </a:p>
           <a:p>
@@ -6554,7 +6374,7 @@
               </a:defRPr>
             </a:pPr>
             <a:r>
-              <a:t>Matching: skill_canonical_map, match_percentage, skill_gaps</a:t>
+              <a:t>• Matching: skill_canonical_map, match_percentage, skill_gaps</a:t>
             </a:r>
           </a:p>
           <a:p>
@@ -6570,7 +6390,7 @@
               </a:defRPr>
             </a:pPr>
             <a:r>
-              <a:t>Resources: web_articles, news, youtube, amazon, courses, blog (merged via reducers)</a:t>
+              <a:t>• Resources: web_articles, news, youtube, amazon, courses, blog (merged via reducers)</a:t>
             </a:r>
           </a:p>
           <a:p>
@@ -6586,7 +6406,7 @@
               </a:defRPr>
             </a:pPr>
             <a:r>
-              <a:t>Output: training_plan, resource_search_warnings</a:t>
+              <a:t>• Output: training_plan, resource_search_warnings</a:t>
             </a:r>
           </a:p>
         </p:txBody>
@@ -6765,7 +6585,7 @@
               </a:defRPr>
             </a:pPr>
             <a:r>
-              <a:t>test_parsers — parse_txt, parse_resume (TXT, PDF, unsupported)</a:t>
+              <a:t>• test_parsers — parse_txt, parse_resume (TXT, PDF, unsupported)</a:t>
             </a:r>
           </a:p>
           <a:p>
@@ -6781,7 +6601,7 @@
               </a:defRPr>
             </a:pPr>
             <a:r>
-              <a:t>test_config — normalize_skill_name, is_programming_language, missing_api_keys</a:t>
+              <a:t>• test_config — normalize_skill_name, is_programming_language, missing_api_keys</a:t>
             </a:r>
           </a:p>
           <a:p>
@@ -6797,7 +6617,7 @@
               </a:defRPr>
             </a:pPr>
             <a:r>
-              <a:t>test_skill_matcher — perfect match, gap detection, synonym matching</a:t>
+              <a:t>• test_skill_matcher — perfect match, gap detection, synonym matching</a:t>
             </a:r>
           </a:p>
           <a:p>
@@ -6813,7 +6633,7 @@
               </a:defRPr>
             </a:pPr>
             <a:r>
-              <a:t>test_resource_finder — _top_gap_skill_names fallbacks</a:t>
+              <a:t>• test_resource_finder — _top_gap_skill_names fallbacks</a:t>
             </a:r>
           </a:p>
           <a:p>
@@ -6829,7 +6649,7 @@
               </a:defRPr>
             </a:pPr>
             <a:r>
-              <a:t>test_export — build_export_json structure</a:t>
+              <a:t>• test_export — build_export_json structure</a:t>
             </a:r>
           </a:p>
           <a:p>
@@ -6845,7 +6665,7 @@
               </a:defRPr>
             </a:pPr>
             <a:r>
-              <a:t>Run: pytest tests/ -v</a:t>
+              <a:t>• Run: pytest tests/ -v</a:t>
             </a:r>
           </a:p>
         </p:txBody>
@@ -7024,7 +6844,7 @@
               </a:defRPr>
             </a:pPr>
             <a:r>
-              <a:t>Uses GPT-4o-mini to judge analysis quality</a:t>
+              <a:t>• Uses GPT-4o-mini to judge analysis quality</a:t>
             </a:r>
           </a:p>
           <a:p>
@@ -7040,7 +6860,7 @@
               </a:defRPr>
             </a:pPr>
             <a:r>
-              <a:t>Test 1: Skill gaps plausible for software engineer JD?</a:t>
+              <a:t>• Test 1: Skill gaps plausible for software engineer JD?</a:t>
             </a:r>
           </a:p>
           <a:p>
@@ -7056,7 +6876,7 @@
               </a:defRPr>
             </a:pPr>
             <a:r>
-              <a:t>Test 2: Training plan prioritizes critical gaps appropriately?</a:t>
+              <a:t>• Test 2: Training plan prioritizes critical gaps appropriately?</a:t>
             </a:r>
           </a:p>
           <a:p>
@@ -7072,7 +6892,7 @@
               </a:defRPr>
             </a:pPr>
             <a:r>
-              <a:t>Test 3: Synonym matching (LLMs vs Large Language Models) correct?</a:t>
+              <a:t>• Test 3: Synonym matching (LLMs vs Large Language Models) correct?</a:t>
             </a:r>
           </a:p>
           <a:p>
@@ -7088,7 +6908,7 @@
               </a:defRPr>
             </a:pPr>
             <a:r>
-              <a:t>Requires OPENAI_API_KEY; skip with SKIP_EVALS=1</a:t>
+              <a:t>• Requires OPENAI_API_KEY; skip with SKIP_EVALS=1</a:t>
             </a:r>
           </a:p>
         </p:txBody>

</xml_diff>

<commit_message>
Add human in the loop to PPTX and readme
</commit_message>
<xml_diff>
--- a/AI_Job_Assistant_Design_Deck.pptx
+++ b/AI_Job_Assistant_Design_Deck.pptx
@@ -3505,7 +3505,7 @@
               </a:defRPr>
             </a:pPr>
             <a:r>
-              <a:t>• Add skill to resume — override UI with Add/Remove, re-analyze from normalize_skills</a:t>
+              <a:t>• Add skill to resume — human-in-the-loop override UI with Add/Remove, re-analyze from normalize_skills</a:t>
             </a:r>
           </a:p>
           <a:p>
@@ -4330,7 +4330,7 @@
               </a:defRPr>
             </a:pPr>
             <a:r>
-              <a:t>• User overrides — add skills, adjust ratings, change domain; re-analyze without re-upload</a:t>
+              <a:t>• Human in the loop — user overrides: add skills, adjust ratings, change domain; re-analyze without re-upload</a:t>
             </a:r>
           </a:p>
         </p:txBody>

</xml_diff>

<commit_message>
Update PPTX and Readme with Future Directions
</commit_message>
<xml_diff>
--- a/AI_Job_Assistant_Design_Deck.pptx
+++ b/AI_Job_Assistant_Design_Deck.pptx
@@ -15,6 +15,7 @@
     <p:sldId id="263" r:id="rId14"/>
     <p:sldId id="264" r:id="rId15"/>
     <p:sldId id="265" r:id="rId16"/>
+    <p:sldId id="266" r:id="rId17"/>
   </p:sldIdLst>
   <p:sldSz cx="9144000" cy="6858000" type="screen4x3"/>
   <p:notesSz cx="6858000" cy="9144000"/>
@@ -3538,6 +3539,233 @@
             </a:pPr>
             <a:r>
               <a:t>• Privacy note — displayed in sidebar</a:t>
+            </a:r>
+          </a:p>
+        </p:txBody>
+      </p:sp>
+    </p:spTree>
+  </p:cSld>
+  <p:clrMapOvr>
+    <a:masterClrMapping/>
+  </p:clrMapOvr>
+</p:sld>
+</file>
+
+<file path=ppt/slides/slide11.xml><?xml version="1.0" encoding="utf-8"?>
+<p:sld xmlns:a="http://schemas.openxmlformats.org/drawingml/2006/main" xmlns:p="http://schemas.openxmlformats.org/presentationml/2006/main" xmlns:r="http://schemas.openxmlformats.org/officeDocument/2006/relationships">
+  <p:cSld>
+    <p:spTree>
+      <p:nvGrpSpPr>
+        <p:cNvPr id="1" name=""/>
+        <p:cNvGrpSpPr/>
+        <p:nvPr/>
+      </p:nvGrpSpPr>
+      <p:grpSpPr/>
+      <p:sp>
+        <p:nvSpPr>
+          <p:cNvPr id="2" name="Rectangle 1"/>
+          <p:cNvSpPr/>
+          <p:nvPr/>
+        </p:nvSpPr>
+        <p:spPr>
+          <a:xfrm>
+            <a:off x="0" y="0"/>
+            <a:ext cx="9144000" cy="137160"/>
+          </a:xfrm>
+          <a:prstGeom prst="rect">
+            <a:avLst/>
+          </a:prstGeom>
+          <a:solidFill>
+            <a:srgbClr val="0F172A"/>
+          </a:solidFill>
+          <a:ln>
+            <a:noFill/>
+          </a:ln>
+        </p:spPr>
+        <p:style>
+          <a:lnRef idx="1">
+            <a:schemeClr val="accent1"/>
+          </a:lnRef>
+          <a:fillRef idx="3">
+            <a:schemeClr val="accent1"/>
+          </a:fillRef>
+          <a:effectRef idx="2">
+            <a:schemeClr val="accent1"/>
+          </a:effectRef>
+          <a:fontRef idx="minor">
+            <a:schemeClr val="lt1"/>
+          </a:fontRef>
+        </p:style>
+        <p:txBody>
+          <a:bodyPr rtlCol="0" anchor="ctr"/>
+          <a:lstStyle/>
+          <a:p>
+            <a:pPr algn="ctr"/>
+          </a:p>
+        </p:txBody>
+      </p:sp>
+      <p:sp>
+        <p:nvSpPr>
+          <p:cNvPr id="3" name="Rectangle 2"/>
+          <p:cNvSpPr/>
+          <p:nvPr/>
+        </p:nvSpPr>
+        <p:spPr>
+          <a:xfrm>
+            <a:off x="0" y="0"/>
+            <a:ext cx="73152" cy="6858000"/>
+          </a:xfrm>
+          <a:prstGeom prst="rect">
+            <a:avLst/>
+          </a:prstGeom>
+          <a:solidFill>
+            <a:srgbClr val="0D9488"/>
+          </a:solidFill>
+          <a:ln>
+            <a:noFill/>
+          </a:ln>
+        </p:spPr>
+        <p:style>
+          <a:lnRef idx="1">
+            <a:schemeClr val="accent1"/>
+          </a:lnRef>
+          <a:fillRef idx="3">
+            <a:schemeClr val="accent1"/>
+          </a:fillRef>
+          <a:effectRef idx="2">
+            <a:schemeClr val="accent1"/>
+          </a:effectRef>
+          <a:fontRef idx="minor">
+            <a:schemeClr val="lt1"/>
+          </a:fontRef>
+        </p:style>
+        <p:txBody>
+          <a:bodyPr rtlCol="0" anchor="ctr"/>
+          <a:lstStyle/>
+          <a:p>
+            <a:pPr algn="ctr"/>
+          </a:p>
+        </p:txBody>
+      </p:sp>
+      <p:sp>
+        <p:nvSpPr>
+          <p:cNvPr id="4" name="TextBox 3"/>
+          <p:cNvSpPr txBox="1"/>
+          <p:nvPr/>
+        </p:nvSpPr>
+        <p:spPr>
+          <a:xfrm>
+            <a:off x="685800" y="548640"/>
+            <a:ext cx="7772400" cy="822960"/>
+          </a:xfrm>
+          <a:prstGeom prst="rect">
+            <a:avLst/>
+          </a:prstGeom>
+          <a:noFill/>
+        </p:spPr>
+        <p:txBody>
+          <a:bodyPr wrap="none">
+            <a:spAutoFit/>
+          </a:bodyPr>
+          <a:lstStyle/>
+          <a:p>
+            <a:pPr>
+              <a:defRPr sz="2800" b="1">
+                <a:solidFill>
+                  <a:srgbClr val="0F172A"/>
+                </a:solidFill>
+                <a:latin typeface="Segoe UI"/>
+              </a:defRPr>
+            </a:pPr>
+            <a:r>
+              <a:t>Future Directions</a:t>
+            </a:r>
+          </a:p>
+        </p:txBody>
+      </p:sp>
+      <p:sp>
+        <p:nvSpPr>
+          <p:cNvPr id="5" name="TextBox 4"/>
+          <p:cNvSpPr txBox="1"/>
+          <p:nvPr/>
+        </p:nvSpPr>
+        <p:spPr>
+          <a:xfrm>
+            <a:off x="685800" y="1371600"/>
+            <a:ext cx="7772400" cy="5029200"/>
+          </a:xfrm>
+          <a:prstGeom prst="rect">
+            <a:avLst/>
+          </a:prstGeom>
+          <a:noFill/>
+        </p:spPr>
+        <p:txBody>
+          <a:bodyPr wrap="square">
+            <a:spAutoFit/>
+          </a:bodyPr>
+          <a:lstStyle/>
+          <a:p>
+            <a:pPr>
+              <a:spcBef>
+                <a:spcPts val="600"/>
+              </a:spcBef>
+              <a:defRPr sz="1600">
+                <a:solidFill>
+                  <a:srgbClr val="334455"/>
+                </a:solidFill>
+                <a:latin typeface="Segoe UI"/>
+              </a:defRPr>
+            </a:pPr>
+            <a:r>
+              <a:t>• Login with credentials — e.g. Google auth for authenticated sessions</a:t>
+            </a:r>
+          </a:p>
+          <a:p>
+            <a:pPr>
+              <a:spcBef>
+                <a:spcPts val="600"/>
+              </a:spcBef>
+              <a:defRPr sz="1600">
+                <a:solidFill>
+                  <a:srgbClr val="334455"/>
+                </a:solidFill>
+                <a:latin typeface="Segoe UI"/>
+              </a:defRPr>
+            </a:pPr>
+            <a:r>
+              <a:t>• Save projects on server — store job description, skills analysis, training plan, and learning resources as a project with a unique name per user</a:t>
+            </a:r>
+          </a:p>
+          <a:p>
+            <a:pPr>
+              <a:spcBef>
+                <a:spcPts val="600"/>
+              </a:spcBef>
+              <a:defRPr sz="1600">
+                <a:solidFill>
+                  <a:srgbClr val="334455"/>
+                </a:solidFill>
+                <a:latin typeface="Segoe UI"/>
+              </a:defRPr>
+            </a:pPr>
+            <a:r>
+              <a:t>• Load previous project — restore a saved project from JSON</a:t>
+            </a:r>
+          </a:p>
+          <a:p>
+            <a:pPr>
+              <a:spcBef>
+                <a:spcPts val="600"/>
+              </a:spcBef>
+              <a:defRPr sz="1600">
+                <a:solidFill>
+                  <a:srgbClr val="334455"/>
+                </a:solidFill>
+                <a:latin typeface="Segoe UI"/>
+              </a:defRPr>
+            </a:pPr>
+            <a:r>
+              <a:t>• Google Calendar integration — add the training plan to the user's Google Calendar based on user-defined days and times</a:t>
             </a:r>
           </a:p>
         </p:txBody>

</xml_diff>

<commit_message>
Add Future Directions, Debug output docs, replace PLs with programming languages, shorten Debug slide title
Made-with: Cursor
</commit_message>
<xml_diff>
--- a/AI_Job_Assistant_Design_Deck.pptx
+++ b/AI_Job_Assistant_Design_Deck.pptx
@@ -16,6 +16,7 @@
     <p:sldId id="264" r:id="rId15"/>
     <p:sldId id="265" r:id="rId16"/>
     <p:sldId id="266" r:id="rId17"/>
+    <p:sldId id="267" r:id="rId18"/>
   </p:sldIdLst>
   <p:sldSz cx="9144000" cy="6858000" type="screen4x3"/>
   <p:notesSz cx="6858000" cy="9144000"/>
@@ -3490,7 +3491,7 @@
               </a:defRPr>
             </a:pPr>
             <a:r>
-              <a:t>• Empty skill_gaps when ignoring PLs — added required_skills_for_resources fallback</a:t>
+              <a:t>• Empty skill_gaps when ignoring programming languages — added required_skills_for_resources fallback</a:t>
             </a:r>
           </a:p>
           <a:p>
@@ -3552,6 +3553,265 @@
 </file>
 
 <file path=ppt/slides/slide11.xml><?xml version="1.0" encoding="utf-8"?>
+<p:sld xmlns:a="http://schemas.openxmlformats.org/drawingml/2006/main" xmlns:p="http://schemas.openxmlformats.org/presentationml/2006/main" xmlns:r="http://schemas.openxmlformats.org/officeDocument/2006/relationships">
+  <p:cSld>
+    <p:spTree>
+      <p:nvGrpSpPr>
+        <p:cNvPr id="1" name=""/>
+        <p:cNvGrpSpPr/>
+        <p:nvPr/>
+      </p:nvGrpSpPr>
+      <p:grpSpPr/>
+      <p:sp>
+        <p:nvSpPr>
+          <p:cNvPr id="2" name="Rectangle 1"/>
+          <p:cNvSpPr/>
+          <p:nvPr/>
+        </p:nvSpPr>
+        <p:spPr>
+          <a:xfrm>
+            <a:off x="0" y="0"/>
+            <a:ext cx="9144000" cy="137160"/>
+          </a:xfrm>
+          <a:prstGeom prst="rect">
+            <a:avLst/>
+          </a:prstGeom>
+          <a:solidFill>
+            <a:srgbClr val="0F172A"/>
+          </a:solidFill>
+          <a:ln>
+            <a:noFill/>
+          </a:ln>
+        </p:spPr>
+        <p:style>
+          <a:lnRef idx="1">
+            <a:schemeClr val="accent1"/>
+          </a:lnRef>
+          <a:fillRef idx="3">
+            <a:schemeClr val="accent1"/>
+          </a:fillRef>
+          <a:effectRef idx="2">
+            <a:schemeClr val="accent1"/>
+          </a:effectRef>
+          <a:fontRef idx="minor">
+            <a:schemeClr val="lt1"/>
+          </a:fontRef>
+        </p:style>
+        <p:txBody>
+          <a:bodyPr rtlCol="0" anchor="ctr"/>
+          <a:lstStyle/>
+          <a:p>
+            <a:pPr algn="ctr"/>
+          </a:p>
+        </p:txBody>
+      </p:sp>
+      <p:sp>
+        <p:nvSpPr>
+          <p:cNvPr id="3" name="Rectangle 2"/>
+          <p:cNvSpPr/>
+          <p:nvPr/>
+        </p:nvSpPr>
+        <p:spPr>
+          <a:xfrm>
+            <a:off x="0" y="0"/>
+            <a:ext cx="73152" cy="6858000"/>
+          </a:xfrm>
+          <a:prstGeom prst="rect">
+            <a:avLst/>
+          </a:prstGeom>
+          <a:solidFill>
+            <a:srgbClr val="0D9488"/>
+          </a:solidFill>
+          <a:ln>
+            <a:noFill/>
+          </a:ln>
+        </p:spPr>
+        <p:style>
+          <a:lnRef idx="1">
+            <a:schemeClr val="accent1"/>
+          </a:lnRef>
+          <a:fillRef idx="3">
+            <a:schemeClr val="accent1"/>
+          </a:fillRef>
+          <a:effectRef idx="2">
+            <a:schemeClr val="accent1"/>
+          </a:effectRef>
+          <a:fontRef idx="minor">
+            <a:schemeClr val="lt1"/>
+          </a:fontRef>
+        </p:style>
+        <p:txBody>
+          <a:bodyPr rtlCol="0" anchor="ctr"/>
+          <a:lstStyle/>
+          <a:p>
+            <a:pPr algn="ctr"/>
+          </a:p>
+        </p:txBody>
+      </p:sp>
+      <p:sp>
+        <p:nvSpPr>
+          <p:cNvPr id="4" name="TextBox 3"/>
+          <p:cNvSpPr txBox="1"/>
+          <p:nvPr/>
+        </p:nvSpPr>
+        <p:spPr>
+          <a:xfrm>
+            <a:off x="685800" y="548640"/>
+            <a:ext cx="7772400" cy="822960"/>
+          </a:xfrm>
+          <a:prstGeom prst="rect">
+            <a:avLst/>
+          </a:prstGeom>
+          <a:noFill/>
+        </p:spPr>
+        <p:txBody>
+          <a:bodyPr wrap="none">
+            <a:spAutoFit/>
+          </a:bodyPr>
+          <a:lstStyle/>
+          <a:p>
+            <a:pPr>
+              <a:defRPr sz="2800" b="1">
+                <a:solidFill>
+                  <a:srgbClr val="0F172A"/>
+                </a:solidFill>
+                <a:latin typeface="Segoe UI"/>
+              </a:defRPr>
+            </a:pPr>
+            <a:r>
+              <a:t>Debug Output (expander at bottom of UI)</a:t>
+            </a:r>
+          </a:p>
+        </p:txBody>
+      </p:sp>
+      <p:sp>
+        <p:nvSpPr>
+          <p:cNvPr id="5" name="TextBox 4"/>
+          <p:cNvSpPr txBox="1"/>
+          <p:nvPr/>
+        </p:nvSpPr>
+        <p:spPr>
+          <a:xfrm>
+            <a:off x="685800" y="1371600"/>
+            <a:ext cx="7772400" cy="5029200"/>
+          </a:xfrm>
+          <a:prstGeom prst="rect">
+            <a:avLst/>
+          </a:prstGeom>
+          <a:noFill/>
+        </p:spPr>
+        <p:txBody>
+          <a:bodyPr wrap="square">
+            <a:spAutoFit/>
+          </a:bodyPr>
+          <a:lstStyle/>
+          <a:p>
+            <a:pPr>
+              <a:spcBef>
+                <a:spcPts val="600"/>
+              </a:spcBef>
+              <a:defRPr sz="1600">
+                <a:solidFill>
+                  <a:srgbClr val="334455"/>
+                </a:solidFill>
+                <a:latin typeface="Segoe UI"/>
+              </a:defRPr>
+            </a:pPr>
+            <a:r>
+              <a:t>• skill_gaps, required_skills, required_skills_for_resources — counts for each</a:t>
+            </a:r>
+          </a:p>
+          <a:p>
+            <a:pPr>
+              <a:spcBef>
+                <a:spcPts val="600"/>
+              </a:spcBef>
+              <a:defRPr sz="1600">
+                <a:solidFill>
+                  <a:srgbClr val="334455"/>
+                </a:solidFill>
+                <a:latin typeface="Segoe UI"/>
+              </a:defRPr>
+            </a:pPr>
+            <a:r>
+              <a:t>• Skills sent to search — which skills were used for resource queries (or fallback)</a:t>
+            </a:r>
+          </a:p>
+          <a:p>
+            <a:pPr>
+              <a:spcBef>
+                <a:spcPts val="600"/>
+              </a:spcBef>
+              <a:defRPr sz="1600">
+                <a:solidFill>
+                  <a:srgbClr val="334455"/>
+                </a:solidFill>
+                <a:latin typeface="Segoe UI"/>
+              </a:defRPr>
+            </a:pPr>
+            <a:r>
+              <a:t>• Sample web query — example Tavily/YouTube query string</a:t>
+            </a:r>
+          </a:p>
+          <a:p>
+            <a:pPr>
+              <a:spcBef>
+                <a:spcPts val="600"/>
+              </a:spcBef>
+              <a:defRPr sz="1600">
+                <a:solidFill>
+                  <a:srgbClr val="334455"/>
+                </a:solidFill>
+                <a:latin typeface="Segoe UI"/>
+              </a:defRPr>
+            </a:pPr>
+            <a:r>
+              <a:t>• Resource counts — web_articles, news, blog, youtube, amazon, courses</a:t>
+            </a:r>
+          </a:p>
+          <a:p>
+            <a:pPr>
+              <a:spcBef>
+                <a:spcPts val="600"/>
+              </a:spcBef>
+              <a:defRPr sz="1600">
+                <a:solidFill>
+                  <a:srgbClr val="334455"/>
+                </a:solidFill>
+                <a:latin typeface="Segoe UI"/>
+              </a:defRPr>
+            </a:pPr>
+            <a:r>
+              <a:t>• Troubleshooting help: when counts are 0, check API keys and skill population</a:t>
+            </a:r>
+          </a:p>
+          <a:p>
+            <a:pPr>
+              <a:spcBef>
+                <a:spcPts val="600"/>
+              </a:spcBef>
+              <a:defRPr sz="1600">
+                <a:solidFill>
+                  <a:srgbClr val="334455"/>
+                </a:solidFill>
+                <a:latin typeface="Segoe UI"/>
+              </a:defRPr>
+            </a:pPr>
+            <a:r>
+              <a:t>• Helped debug: learning resources not showing, Tavily returning 0, empty skill_gaps when ignoring programming languages, API errors</a:t>
+            </a:r>
+          </a:p>
+        </p:txBody>
+      </p:sp>
+    </p:spTree>
+  </p:cSld>
+  <p:clrMapOvr>
+    <a:masterClrMapping/>
+  </p:clrMapOvr>
+</p:sld>
+</file>
+
+<file path=ppt/slides/slide12.xml><?xml version="1.0" encoding="utf-8"?>
 <p:sld xmlns:a="http://schemas.openxmlformats.org/drawingml/2006/main" xmlns:p="http://schemas.openxmlformats.org/presentationml/2006/main" xmlns:r="http://schemas.openxmlformats.org/officeDocument/2006/relationships">
   <p:cSld>
     <p:spTree>

</xml_diff>